<commit_message>
Redesenha as telas do tacógrafo em alta resolução para o manual
As fotos do vídeo (576x326) ficavam ilegíveis no PPTX. render_telas.py
desenha cada tela do visor com o texto exato, destaca os botões a
pressionar e mantém a foto real como miniatura de referência.

Co-Authored-By: Claude Opus 5.5 <noreply@anthropic.com>
Claude-Session: https://claude.ai/code/session_01Mf1iaDuu7MKrCtXvgRinDy
</commit_message>
<xml_diff>
--- a/tacografo/Manual_Tacografo_Digital.pptx
+++ b/tacografo/Manual_Tacografo_Digital.pptx
@@ -127,14 +127,14 @@
   <p:extLst>
     <p:ext uri="{521415D9-36F7-43E2-AB2F-B90AF26B5E84}">
       <p14:sectionLst xmlns:p14="http://schemas.microsoft.com/office/powerpoint/2010/main">
-        <p14:section name="Introdução" id="{be8ed9cb-beb9-09e9-b759-8a2a3e80449f}">
+        <p14:section name="Introdução" id="{8674cc17-b043-73a8-6862-f707e657783c}">
           <p14:sldIdLst>
             <p14:sldId id="256"/>
             <p14:sldId id="257"/>
             <p14:sldId id="258"/>
           </p14:sldIdLst>
         </p14:section>
-        <p14:section name="Parte 1 · Cadastrar" id="{4ecc1a41-5fe5-d8a6-546b-134d9e0f9fed}">
+        <p14:section name="Parte 1 · Cadastrar" id="{199d8618-2aeb-8e18-5388-78f4572948d7}">
           <p14:sldIdLst>
             <p14:sldId id="259"/>
             <p14:sldId id="260"/>
@@ -146,7 +146,7 @@
             <p14:sldId id="266"/>
           </p14:sldIdLst>
         </p14:section>
-        <p14:section name="Parte 2 · Conectar" id="{1d1456c0-6034-3e5b-1f9f-57c8cc89ea08}">
+        <p14:section name="Parte 2 · Conectar" id="{13442ca0-802e-8618-7cbd-83c4a8288c3e}">
           <p14:sldIdLst>
             <p14:sldId id="267"/>
             <p14:sldId id="268"/>
@@ -156,13 +156,13 @@
             <p14:sldId id="272"/>
           </p14:sldIdLst>
         </p14:section>
-        <p14:section name="Parte 3 · Desconectar" id="{dc496df6-0a9b-1c3b-45c2-75fbd5b3525b}">
+        <p14:section name="Parte 3 · Desconectar" id="{47f9da88-6370-af53-31c1-e284fe47e0f5}">
           <p14:sldIdLst>
             <p14:sldId id="273"/>
             <p14:sldId id="274"/>
           </p14:sldIdLst>
         </p14:section>
-        <p14:section name="Encerramento" id="{ad30cbf2-e0f2-4c42-6b56-be9bb43f6755}">
+        <p14:section name="Encerramento" id="{65b5cfc2-d3b0-f1ce-e3d9-beba78f30e90}">
           <p14:sldIdLst>
             <p14:sldId id="275"/>
             <p14:sldId id="276"/>
@@ -3499,7 +3499,7 @@
       </p:sp>
       <p:pic>
         <p:nvPicPr>
-          <p:cNvPr id="6" name="print" descr="/home/user/Manuais-de-uso/tacografo/prints/09_confirma.jpg">    </p:cNvPr>
+          <p:cNvPr id="6" name="print" descr="/home/user/Manuais-de-uso/tacografo/telas/09_confirma.jpg">    </p:cNvPr>
           <p:cNvPicPr>
             <a:picLocks noChangeAspect="1"/>
           </p:cNvPicPr>
@@ -3971,7 +3971,7 @@
       </p:sp>
       <p:pic>
         <p:nvPicPr>
-          <p:cNvPr id="6" name="print" descr="/home/user/Manuais-de-uso/tacografo/prints/10_cadastrado.jpg">    </p:cNvPr>
+          <p:cNvPr id="6" name="print" descr="/home/user/Manuais-de-uso/tacografo/telas/10_cadastrado.jpg">    </p:cNvPr>
           <p:cNvPicPr>
             <a:picLocks noChangeAspect="1"/>
           </p:cNvPicPr>
@@ -4496,7 +4496,7 @@
       </p:sp>
       <p:pic>
         <p:nvPicPr>
-          <p:cNvPr id="6" name="print-1" descr="/home/user/Manuais-de-uso/tacografo/prints/11_inicial.jpg">    </p:cNvPr>
+          <p:cNvPr id="6" name="print-1" descr="/home/user/Manuais-de-uso/tacografo/telas/11_inicial.jpg">    </p:cNvPr>
           <p:cNvPicPr>
             <a:picLocks noChangeAspect="1"/>
           </p:cNvPicPr>
@@ -4588,7 +4588,7 @@
       </p:sp>
       <p:pic>
         <p:nvPicPr>
-          <p:cNvPr id="9" name="print-2" descr="/home/user/Manuais-de-uso/tacografo/prints/12_menu_mot.jpg">    </p:cNvPr>
+          <p:cNvPr id="9" name="print-2" descr="/home/user/Manuais-de-uso/tacografo/telas/12_menu_mot.jpg">    </p:cNvPr>
           <p:cNvPicPr>
             <a:picLocks noChangeAspect="1"/>
           </p:cNvPicPr>
@@ -5131,7 +5131,7 @@
       </p:sp>
       <p:pic>
         <p:nvPicPr>
-          <p:cNvPr id="6" name="print-1" descr="/home/user/Manuais-de-uso/tacografo/prints/13_conecte.jpg">    </p:cNvPr>
+          <p:cNvPr id="6" name="print-1" descr="/home/user/Manuais-de-uso/tacografo/telas/13_conecte.jpg">    </p:cNvPr>
           <p:cNvPicPr>
             <a:picLocks noChangeAspect="1"/>
           </p:cNvPicPr>
@@ -5223,7 +5223,7 @@
       </p:sp>
       <p:pic>
         <p:nvPicPr>
-          <p:cNvPr id="9" name="print-2" descr="/home/user/Manuais-de-uso/tacografo/prints/14_viagem.jpg">    </p:cNvPr>
+          <p:cNvPr id="9" name="print-2" descr="/home/user/Manuais-de-uso/tacografo/telas/14_viagem.jpg">    </p:cNvPr>
           <p:cNvPicPr>
             <a:picLocks noChangeAspect="1"/>
           </p:cNvPicPr>
@@ -5766,7 +5766,7 @@
       </p:sp>
       <p:pic>
         <p:nvPicPr>
-          <p:cNvPr id="6" name="print" descr="/home/user/Manuais-de-uso/tacografo/prints/15_manual_lista.jpg">    </p:cNvPr>
+          <p:cNvPr id="6" name="print" descr="/home/user/Manuais-de-uso/tacografo/telas/15_manual_lista.jpg">    </p:cNvPr>
           <p:cNvPicPr>
             <a:picLocks noChangeAspect="1"/>
           </p:cNvPicPr>
@@ -6217,7 +6217,7 @@
       </p:sp>
       <p:pic>
         <p:nvPicPr>
-          <p:cNvPr id="6" name="print-1" descr="/home/user/Manuais-de-uso/tacografo/prints/16_lista01.jpg">    </p:cNvPr>
+          <p:cNvPr id="6" name="print-1" descr="/home/user/Manuais-de-uso/tacografo/telas/16_lista01.jpg">    </p:cNvPr>
           <p:cNvPicPr>
             <a:picLocks noChangeAspect="1"/>
           </p:cNvPicPr>
@@ -6309,7 +6309,7 @@
       </p:sp>
       <p:pic>
         <p:nvPicPr>
-          <p:cNvPr id="9" name="print-2" descr="/home/user/Manuais-de-uso/tacografo/prints/17_lista02.jpg">    </p:cNvPr>
+          <p:cNvPr id="9" name="print-2" descr="/home/user/Manuais-de-uso/tacografo/telas/17_lista02.jpg">    </p:cNvPr>
           <p:cNvPicPr>
             <a:picLocks noChangeAspect="1"/>
           </p:cNvPicPr>
@@ -6852,7 +6852,7 @@
       </p:sp>
       <p:pic>
         <p:nvPicPr>
-          <p:cNvPr id="6" name="print-1" descr="/home/user/Manuais-de-uso/tacografo/prints/18_confirma_con.jpg">    </p:cNvPr>
+          <p:cNvPr id="6" name="print-1" descr="/home/user/Manuais-de-uso/tacografo/telas/18_confirma_con.jpg">    </p:cNvPr>
           <p:cNvPicPr>
             <a:picLocks noChangeAspect="1"/>
           </p:cNvPicPr>
@@ -6944,7 +6944,7 @@
       </p:sp>
       <p:pic>
         <p:nvPicPr>
-          <p:cNvPr id="9" name="print-2" descr="/home/user/Manuais-de-uso/tacografo/prints/19_conectado.jpg">    </p:cNvPr>
+          <p:cNvPr id="9" name="print-2" descr="/home/user/Manuais-de-uso/tacografo/telas/19_conectado.jpg">    </p:cNvPr>
           <p:cNvPicPr>
             <a:picLocks noChangeAspect="1"/>
           </p:cNvPicPr>
@@ -7572,7 +7572,7 @@
       </p:sp>
       <p:pic>
         <p:nvPicPr>
-          <p:cNvPr id="6" name="print-1" descr="/home/user/Manuais-de-uso/tacografo/prints/20_menu_mot2.jpg">    </p:cNvPr>
+          <p:cNvPr id="6" name="print-1" descr="/home/user/Manuais-de-uso/tacografo/telas/20_menu_mot2.jpg">    </p:cNvPr>
           <p:cNvPicPr>
             <a:picLocks noChangeAspect="1"/>
           </p:cNvPicPr>
@@ -7664,7 +7664,7 @@
       </p:sp>
       <p:pic>
         <p:nvPicPr>
-          <p:cNvPr id="9" name="print-2" descr="/home/user/Manuais-de-uso/tacografo/prints/21_desconectar.jpg">    </p:cNvPr>
+          <p:cNvPr id="9" name="print-2" descr="/home/user/Manuais-de-uso/tacografo/telas/21_desconectar.jpg">    </p:cNvPr>
           <p:cNvPicPr>
             <a:picLocks noChangeAspect="1"/>
           </p:cNvPicPr>
@@ -7756,7 +7756,7 @@
       </p:sp>
       <p:pic>
         <p:nvPicPr>
-          <p:cNvPr id="12" name="print-3" descr="/home/user/Manuais-de-uso/tacografo/prints/22_desconectado.jpg">    </p:cNvPr>
+          <p:cNvPr id="12" name="print-3" descr="/home/user/Manuais-de-uso/tacografo/telas/22_desconectado.jpg">    </p:cNvPr>
           <p:cNvPicPr>
             <a:picLocks noChangeAspect="1"/>
           </p:cNvPicPr>
@@ -8076,7 +8076,7 @@
       </p:sp>
       <p:pic>
         <p:nvPicPr>
-          <p:cNvPr id="6" name="tela-inicial" descr="/home/user/Manuais-de-uso/tacografo/prints/01_inicial.jpg">    </p:cNvPr>
+          <p:cNvPr id="6" name="tela-inicial" descr="/home/user/Manuais-de-uso/tacografo/telas/01_inicial.jpg">    </p:cNvPr>
           <p:cNvPicPr>
             <a:picLocks noChangeAspect="1"/>
           </p:cNvPicPr>
@@ -10560,7 +10560,7 @@
       </p:sp>
       <p:pic>
         <p:nvPicPr>
-          <p:cNvPr id="6" name="print" descr="/home/user/Manuais-de-uso/tacografo/prints/02_gerenciamento.jpg">    </p:cNvPr>
+          <p:cNvPr id="6" name="print" descr="/home/user/Manuais-de-uso/tacografo/telas/02_gerenciamento.jpg">    </p:cNvPr>
           <p:cNvPicPr>
             <a:picLocks noChangeAspect="1"/>
           </p:cNvPicPr>
@@ -11072,7 +11072,7 @@
       </p:sp>
       <p:pic>
         <p:nvPicPr>
-          <p:cNvPr id="6" name="print-1" descr="/home/user/Manuais-de-uso/tacografo/prints/03_remover.jpg">    </p:cNvPr>
+          <p:cNvPr id="6" name="print-1" descr="/home/user/Manuais-de-uso/tacografo/telas/03_remover.jpg">    </p:cNvPr>
           <p:cNvPicPr>
             <a:picLocks noChangeAspect="1"/>
           </p:cNvPicPr>
@@ -11164,7 +11164,7 @@
       </p:sp>
       <p:pic>
         <p:nvPicPr>
-          <p:cNvPr id="9" name="print-2" descr="/home/user/Manuais-de-uso/tacografo/prints/04_cadastrar.jpg">    </p:cNvPr>
+          <p:cNvPr id="9" name="print-2" descr="/home/user/Manuais-de-uso/tacografo/telas/04_cadastrar.jpg">    </p:cNvPr>
           <p:cNvPicPr>
             <a:picLocks noChangeAspect="1"/>
           </p:cNvPicPr>
@@ -11707,7 +11707,7 @@
       </p:sp>
       <p:pic>
         <p:nvPicPr>
-          <p:cNvPr id="6" name="print" descr="/home/user/Manuais-de-uso/tacografo/prints/05_bvdr.jpg">    </p:cNvPr>
+          <p:cNvPr id="6" name="print" descr="/home/user/Manuais-de-uso/tacografo/telas/05_bvdr.jpg">    </p:cNvPr>
           <p:cNvPicPr>
             <a:picLocks noChangeAspect="1"/>
           </p:cNvPicPr>
@@ -12219,7 +12219,7 @@
       </p:sp>
       <p:pic>
         <p:nvPicPr>
-          <p:cNvPr id="6" name="print" descr="/home/user/Manuais-de-uso/tacografo/prints/06_codigo.jpg">    </p:cNvPr>
+          <p:cNvPr id="6" name="print" descr="/home/user/Manuais-de-uso/tacografo/telas/06_codigo.jpg">    </p:cNvPr>
           <p:cNvPicPr>
             <a:picLocks noChangeAspect="1"/>
           </p:cNvPicPr>
@@ -12752,7 +12752,7 @@
       </p:sp>
       <p:pic>
         <p:nvPicPr>
-          <p:cNvPr id="6" name="print-1" descr="/home/user/Manuais-de-uso/tacografo/prints/07_cnh_vazio.jpg">    </p:cNvPr>
+          <p:cNvPr id="6" name="print-1" descr="/home/user/Manuais-de-uso/tacografo/telas/07_cnh_vazio.jpg">    </p:cNvPr>
           <p:cNvPicPr>
             <a:picLocks noChangeAspect="1"/>
           </p:cNvPicPr>
@@ -12844,7 +12844,7 @@
       </p:sp>
       <p:pic>
         <p:nvPicPr>
-          <p:cNvPr id="9" name="print-2" descr="/home/user/Manuais-de-uso/tacografo/prints/08_cnh.jpg">    </p:cNvPr>
+          <p:cNvPr id="9" name="print-2" descr="/home/user/Manuais-de-uso/tacografo/telas/08_cnh.jpg">    </p:cNvPr>
           <p:cNvPicPr>
             <a:picLocks noChangeAspect="1"/>
           </p:cNvPicPr>

</xml_diff>

<commit_message>
BVDR: resposta SIM; roteiro para ElevenLabs e script de montagem do vídeo
Co-Authored-By: Claude Opus 5.5 <noreply@anthropic.com>
Claude-Session: https://claude.ai/code/session_01Mf1iaDuu7MKrCtXvgRinDy
</commit_message>
<xml_diff>
--- a/tacografo/Manual_Tacografo_Digital.pptx
+++ b/tacografo/Manual_Tacografo_Digital.pptx
@@ -127,14 +127,14 @@
   <p:extLst>
     <p:ext uri="{521415D9-36F7-43E2-AB2F-B90AF26B5E84}">
       <p14:sectionLst xmlns:p14="http://schemas.microsoft.com/office/powerpoint/2010/main">
-        <p14:section name="Introdução" id="{8674cc17-b043-73a8-6862-f707e657783c}">
+        <p14:section name="Introdução" id="{eb1ce2af-af2d-1460-a6ff-f3a66076ef85}">
           <p14:sldIdLst>
             <p14:sldId id="256"/>
             <p14:sldId id="257"/>
             <p14:sldId id="258"/>
           </p14:sldIdLst>
         </p14:section>
-        <p14:section name="Parte 1 · Cadastrar" id="{199d8618-2aeb-8e18-5388-78f4572948d7}">
+        <p14:section name="Parte 1 · Cadastrar" id="{822eaf0a-2b9d-e4d8-c452-ebf0dfba563f}">
           <p14:sldIdLst>
             <p14:sldId id="259"/>
             <p14:sldId id="260"/>
@@ -146,7 +146,7 @@
             <p14:sldId id="266"/>
           </p14:sldIdLst>
         </p14:section>
-        <p14:section name="Parte 2 · Conectar" id="{13442ca0-802e-8618-7cbd-83c4a8288c3e}">
+        <p14:section name="Parte 2 · Conectar" id="{0c43a0e5-a222-a51c-da00-a4f81b073a54}">
           <p14:sldIdLst>
             <p14:sldId id="267"/>
             <p14:sldId id="268"/>
@@ -156,13 +156,13 @@
             <p14:sldId id="272"/>
           </p14:sldIdLst>
         </p14:section>
-        <p14:section name="Parte 3 · Desconectar" id="{47f9da88-6370-af53-31c1-e284fe47e0f5}">
+        <p14:section name="Parte 3 · Desconectar" id="{e03ea8a8-8334-1b63-05d2-31ac52a8c37e}">
           <p14:sldIdLst>
             <p14:sldId id="273"/>
             <p14:sldId id="274"/>
           </p14:sldIdLst>
         </p14:section>
-        <p14:section name="Encerramento" id="{65b5cfc2-d3b0-f1ce-e3d9-beba78f30e90}">
+        <p14:section name="Encerramento" id="{b1314031-6513-263e-361b-c5981351c44e}">
           <p14:sldIdLst>
             <p14:sldId id="275"/>
             <p14:sldId id="276"/>
@@ -660,7 +660,7 @@
           <a:p>
             <a:r>
               <a:rPr lang="en-US" dirty="0"/>
-              <a:t>O tacógrafo mostra o código e o número da CNH digitados. Confira com atenção. Se estiver tudo certo, selecione Sim e pressione OK. Se houver algum erro, escolha Não e digite novamente.</a:t>
+              <a:t>O tacógrafo mostra o código e o número da C N H digitados. Confira com atenção. Se estiver tudo certo, selecione Sim e pressione OK. Se houver algum erro, escolha Não e digite novamente.</a:t>
             </a:r>
             <a:endParaRPr lang="en-US" dirty="0"/>
           </a:p>
@@ -1276,7 +1276,7 @@
           <a:p>
             <a:r>
               <a:rPr lang="en-US" dirty="0"/>
-              <a:t>Confira o código e a CNH, selecione Sim e pressione OK. De volta à tela inicial, observe que o seu código agora aparece no canto direito. Isso indica que você está conectado e pronto para iniciar a viagem.</a:t>
+              <a:t>Confira o código e a C N H, selecione Sim e pressione OK. De volta à tela inicial, observe que o seu código agora aparece no canto direito. Isso indica que você está conectado e pronto para iniciar a viagem.</a:t>
             </a:r>
             <a:endParaRPr lang="en-US" dirty="0"/>
           </a:p>
@@ -1628,7 +1628,7 @@
           <a:p>
             <a:r>
               <a:rPr lang="en-US" dirty="0"/>
-              <a:t>Recapitulando: para cadastrar, acesse Gerenciamento da lista, escolha Cadastrar, informe o código e a CNH e confirme. Para conectar, vá ao Menu do motorista, escolha Conecte-se, depois Lista de motoristas, selecione o seu código e confirme. Para desconectar, vá ao Menu do motorista e confirme a desconexão. Lembre-se: faça tudo com o veículo parado e sempre confira o seu código na tela inicial antes de sair. Boa viagem!</a:t>
+              <a:t>Recapitulando: para cadastrar, acesse Gerenciamento da lista, escolha Cadastrar, informe o código e a C N H e confirme. Para conectar, vá ao Menu do motorista, escolha Conecte-se, depois Lista de motoristas, selecione o seu código e confirme. Para desconectar, vá ao Menu do motorista e confirme a desconexão. Lembre-se: faça tudo com o veículo parado e sempre confira o seu código na tela inicial antes de sair. Boa viagem!</a:t>
             </a:r>
             <a:endParaRPr lang="en-US" dirty="0"/>
           </a:p>
@@ -2156,7 +2156,7 @@
           <a:p>
             <a:r>
               <a:rPr lang="en-US" dirty="0"/>
-              <a:t>O tacógrafo vai perguntar se deseja gravar a informação do motorista no BVDR. Escolha a resposta com as setas, de acordo com a orientação da sua empresa, e confirme com OK.</a:t>
+              <a:t>O tacógrafo vai perguntar se deseja gravar a informação do motorista no B V D R. Selecione a opção Sim, usando a seta para baixo, e confirme com OK.</a:t>
             </a:r>
             <a:endParaRPr lang="en-US" dirty="0"/>
           </a:p>
@@ -2332,7 +2332,7 @@
           <a:p>
             <a:r>
               <a:rPr lang="en-US" dirty="0"/>
-              <a:t>Na sequência, aparece a tela Digite a habilitação do motorista. Informe o número da CNH usando o mesmo método: as setas escolhem o número e o OK avança para o próximo dígito, até preencher o campo inteiro.</a:t>
+              <a:t>Na sequência, aparece a tela Digite a habilitação do motorista. Informe o número da C N H usando o mesmo método: as setas escolhem o número e o OK avança para o próximo dígito, até preencher o campo inteiro.</a:t>
             </a:r>
             <a:endParaRPr lang="en-US" dirty="0"/>
           </a:p>
@@ -11631,7 +11631,7 @@
                 <a:ea typeface="Montserrat ExtraBold" pitchFamily="34" charset="-122"/>
                 <a:cs typeface="Montserrat ExtraBold" pitchFamily="34" charset="-120"/>
               </a:rPr>
-              <a:t>Gravar informação no BVDR</a:t>
+              <a:t>Grave a informação no BVDR</a:t>
             </a:r>
             <a:endParaRPr lang="en-US" sz="2400" dirty="0"/>
           </a:p>
@@ -11846,7 +11846,7 @@
                 <a:ea typeface="Montserrat Medium" pitchFamily="34" charset="-122"/>
                 <a:cs typeface="Montserrat Medium" pitchFamily="34" charset="-120"/>
               </a:rPr>
-              <a:t>Escolha NÃO ou SIM com ▲ ou ▼, conforme a orientação da empresa, e pressione OK</a:t>
+              <a:t>Selecione SIM com ▼ e pressione OK</a:t>
             </a:r>
             <a:endParaRPr lang="en-US" sz="1300" dirty="0"/>
           </a:p>
@@ -11907,7 +11907,7 @@
                 <a:ea typeface="Arial" pitchFamily="34" charset="-122"/>
                 <a:cs typeface="Arial" pitchFamily="34" charset="-120"/>
               </a:rPr>
-              <a:t>▲</a:t>
+              <a:t>▼</a:t>
             </a:r>
             <a:endParaRPr lang="en-US" sz="1300" dirty="0"/>
           </a:p>
@@ -11944,67 +11944,6 @@
         <p:spPr>
           <a:xfrm>
             <a:off x="6190488" y="4087368"/>
-            <a:ext cx="502920" cy="365760"/>
-          </a:xfrm>
-          <a:prstGeom prst="rect">
-            <a:avLst/>
-          </a:prstGeom>
-          <a:noFill/>
-          <a:ln/>
-        </p:spPr>
-        <p:txBody>
-          <a:bodyPr wrap="square" lIns="0" tIns="0" rIns="0" bIns="0" rtlCol="0" anchor="ctr"/>
-          <a:lstStyle/>
-          <a:p>
-            <a:pPr algn="ctr" indent="0" marL="0">
-              <a:buNone/>
-            </a:pPr>
-            <a:r>
-              <a:rPr lang="en-US" sz="1300" b="1" dirty="0">
-                <a:solidFill>
-                  <a:schemeClr val="bg1"/>
-                </a:solidFill>
-                <a:latin typeface="Arial" pitchFamily="34" charset="0"/>
-                <a:ea typeface="Arial" pitchFamily="34" charset="-122"/>
-                <a:cs typeface="Arial" pitchFamily="34" charset="-120"/>
-              </a:rPr>
-              <a:t>▼</a:t>
-            </a:r>
-            <a:endParaRPr lang="en-US" sz="1300" dirty="0"/>
-          </a:p>
-        </p:txBody>
-      </p:sp>
-      <p:sp>
-        <p:nvSpPr>
-          <p:cNvPr id="14" name="botao-2"/>
-          <p:cNvSpPr/>
-          <p:nvPr/>
-        </p:nvSpPr>
-        <p:spPr>
-          <a:xfrm>
-            <a:off x="6803136" y="4087368"/>
-            <a:ext cx="502920" cy="365760"/>
-          </a:xfrm>
-          <a:prstGeom prst="roundRect">
-            <a:avLst>
-              <a:gd name="adj" fmla="val 20000"/>
-            </a:avLst>
-          </a:prstGeom>
-          <a:solidFill>
-            <a:schemeClr val="tx2"/>
-          </a:solidFill>
-          <a:ln/>
-        </p:spPr>
-      </p:sp>
-      <p:sp>
-        <p:nvSpPr>
-          <p:cNvPr id="15" name="Text 11"/>
-          <p:cNvSpPr txBox="1"/>
-          <p:nvPr/>
-        </p:nvSpPr>
-        <p:spPr>
-          <a:xfrm>
-            <a:off x="6803136" y="4087368"/>
             <a:ext cx="502920" cy="365760"/>
           </a:xfrm>
           <a:prstGeom prst="rect">

</xml_diff>

<commit_message>
Gera o vídeo narrado com revelação progressiva das instruções
build_video.py sincroniza cada item do slide com o momento em que a
narração fala dele (frases-gatilho em roteiro.json + pausas do áudio).

Co-Authored-By: Claude Opus 5.5 <noreply@anthropic.com>
Claude-Session: https://claude.ai/code/session_01Mf1iaDuu7MKrCtXvgRinDy
</commit_message>
<xml_diff>
--- a/tacografo/Manual_Tacografo_Digital.pptx
+++ b/tacografo/Manual_Tacografo_Digital.pptx
@@ -127,14 +127,14 @@
   <p:extLst>
     <p:ext uri="{521415D9-36F7-43E2-AB2F-B90AF26B5E84}">
       <p14:sectionLst xmlns:p14="http://schemas.microsoft.com/office/powerpoint/2010/main">
-        <p14:section name="Introdução" id="{eb1ce2af-af2d-1460-a6ff-f3a66076ef85}">
+        <p14:section name="Introdução" id="{71e1508c-5030-06cd-a68a-fc029345f89a}">
           <p14:sldIdLst>
             <p14:sldId id="256"/>
             <p14:sldId id="257"/>
             <p14:sldId id="258"/>
           </p14:sldIdLst>
         </p14:section>
-        <p14:section name="Parte 1 · Cadastrar" id="{822eaf0a-2b9d-e4d8-c452-ebf0dfba563f}">
+        <p14:section name="Parte 1 · Cadastrar" id="{3bd69945-b061-f744-b78f-ebc5aa6123e0}">
           <p14:sldIdLst>
             <p14:sldId id="259"/>
             <p14:sldId id="260"/>
@@ -146,7 +146,7 @@
             <p14:sldId id="266"/>
           </p14:sldIdLst>
         </p14:section>
-        <p14:section name="Parte 2 · Conectar" id="{0c43a0e5-a222-a51c-da00-a4f81b073a54}">
+        <p14:section name="Parte 2 · Conectar" id="{d4a52dde-a4d4-fe29-cbf4-c88d69851bab}">
           <p14:sldIdLst>
             <p14:sldId id="267"/>
             <p14:sldId id="268"/>
@@ -156,13 +156,13 @@
             <p14:sldId id="272"/>
           </p14:sldIdLst>
         </p14:section>
-        <p14:section name="Parte 3 · Desconectar" id="{e03ea8a8-8334-1b63-05d2-31ac52a8c37e}">
+        <p14:section name="Parte 3 · Desconectar" id="{39097154-18a4-052f-c0a9-7eb1ea10f4b3}">
           <p14:sldIdLst>
             <p14:sldId id="273"/>
             <p14:sldId id="274"/>
           </p14:sldIdLst>
         </p14:section>
-        <p14:section name="Encerramento" id="{b1314031-6513-263e-361b-c5981351c44e}">
+        <p14:section name="Encerramento" id="{41802665-e669-4bdd-9653-16e117779211}">
           <p14:sldIdLst>
             <p14:sldId id="275"/>
             <p14:sldId id="276"/>

</xml_diff>

<commit_message>
Explica que o código do motorista são os 5 primeiros dígitos do CPF
Co-Authored-By: Claude Opus 5.5 <noreply@anthropic.com>
Claude-Session: https://claude.ai/code/session_01Mf1iaDuu7MKrCtXvgRinDy
</commit_message>
<xml_diff>
--- a/tacografo/Manual_Tacografo_Digital.pptx
+++ b/tacografo/Manual_Tacografo_Digital.pptx
@@ -127,14 +127,14 @@
   <p:extLst>
     <p:ext uri="{521415D9-36F7-43E2-AB2F-B90AF26B5E84}">
       <p14:sectionLst xmlns:p14="http://schemas.microsoft.com/office/powerpoint/2010/main">
-        <p14:section name="Introdução" id="{71e1508c-5030-06cd-a68a-fc029345f89a}">
+        <p14:section name="Introdução" id="{aa02f55a-a583-8daf-c2f9-46333bc2c696}">
           <p14:sldIdLst>
             <p14:sldId id="256"/>
             <p14:sldId id="257"/>
             <p14:sldId id="258"/>
           </p14:sldIdLst>
         </p14:section>
-        <p14:section name="Parte 1 · Cadastrar" id="{3bd69945-b061-f744-b78f-ebc5aa6123e0}">
+        <p14:section name="Parte 1 · Cadastrar" id="{aab8aebb-0016-6691-d7b2-4b51ccdafec0}">
           <p14:sldIdLst>
             <p14:sldId id="259"/>
             <p14:sldId id="260"/>
@@ -146,7 +146,7 @@
             <p14:sldId id="266"/>
           </p14:sldIdLst>
         </p14:section>
-        <p14:section name="Parte 2 · Conectar" id="{d4a52dde-a4d4-fe29-cbf4-c88d69851bab}">
+        <p14:section name="Parte 2 · Conectar" id="{640ef9d8-5a52-d152-8e63-11349bbe5929}">
           <p14:sldIdLst>
             <p14:sldId id="267"/>
             <p14:sldId id="268"/>
@@ -156,13 +156,13 @@
             <p14:sldId id="272"/>
           </p14:sldIdLst>
         </p14:section>
-        <p14:section name="Parte 3 · Desconectar" id="{39097154-18a4-052f-c0a9-7eb1ea10f4b3}">
+        <p14:section name="Parte 3 · Desconectar" id="{d2e103b1-9cb8-9605-5a39-155880508fc0}">
           <p14:sldIdLst>
             <p14:sldId id="273"/>
             <p14:sldId id="274"/>
           </p14:sldIdLst>
         </p14:section>
-        <p14:section name="Encerramento" id="{41802665-e669-4bdd-9653-16e117779211}">
+        <p14:section name="Encerramento" id="{21368106-6f7c-faa4-524c-68d2f3eb1aea}">
           <p14:sldIdLst>
             <p14:sldId id="275"/>
             <p14:sldId id="276"/>
@@ -2244,7 +2244,7 @@
           <a:p>
             <a:r>
               <a:rPr lang="en-US" dirty="0"/>
-              <a:t>Agora, digite o código do motorista. Use as setas para escolher o número de cada dígito e pressione OK para passar para o próximo. Repita até completar o código. No exemplo, o código utilizado foi nove nove nove nove nove.</a:t>
+              <a:t>Agora, digite o código do motorista. Ele é formado pelos cinco primeiros dígitos do C P F do motorista. Use as setas para escolher o número de cada dígito e pressione OK para passar para o próximo, até completar os cinco dígitos. No exemplo, o C P F começa com nove nove nove nove nove, então o código é nove nove nove nove nove.</a:t>
             </a:r>
             <a:endParaRPr lang="en-US" dirty="0"/>
           </a:p>
@@ -8974,7 +8974,7 @@
                 <a:ea typeface="Montserrat Medium" pitchFamily="34" charset="-122"/>
                 <a:cs typeface="Montserrat Medium" pitchFamily="34" charset="-120"/>
               </a:rPr>
-              <a:t>Código + CNH</a:t>
+              <a:t>Código (CPF) + CNH</a:t>
             </a:r>
             <a:endParaRPr lang="en-US" sz="1100" dirty="0"/>
           </a:p>
@@ -12276,7 +12276,7 @@
                 <a:ea typeface="Montserrat Medium" pitchFamily="34" charset="-122"/>
                 <a:cs typeface="Montserrat Medium" pitchFamily="34" charset="-120"/>
               </a:rPr>
-              <a:t>Use ▲ ou ▼ para escolher o número de cada dígito</a:t>
+              <a:t>O código são os 5 primeiros dígitos do CPF do motorista</a:t>
             </a:r>
             <a:endParaRPr lang="en-US" sz="1300" dirty="0"/>
           </a:p>
@@ -12297,7 +12297,7 @@
                 <a:ea typeface="Montserrat Medium" pitchFamily="34" charset="-122"/>
                 <a:cs typeface="Montserrat Medium" pitchFamily="34" charset="-120"/>
               </a:rPr>
-              <a:t>Pressione OK para passar ao próximo dígito</a:t>
+              <a:t>Use ▲ ou ▼ para escolher cada número e OK para avançar</a:t>
             </a:r>
             <a:endParaRPr lang="en-US" sz="1300" dirty="0"/>
           </a:p>
@@ -12318,7 +12318,7 @@
                 <a:ea typeface="Montserrat Medium" pitchFamily="34" charset="-122"/>
                 <a:cs typeface="Montserrat Medium" pitchFamily="34" charset="-120"/>
               </a:rPr>
-              <a:t>Repita até completar o código (no exemplo, 99999)</a:t>
+              <a:t>Exemplo: CPF que começa com 999.99 → código 99999</a:t>
             </a:r>
             <a:endParaRPr lang="en-US" sz="1300" dirty="0"/>
           </a:p>

</xml_diff>

<commit_message>
Código do motorista: 4 ou 5 primeiros dígitos do CPF, conforme o modelo
Co-Authored-By: Claude Opus 5.5 <noreply@anthropic.com>
Claude-Session: https://claude.ai/code/session_01Mf1iaDuu7MKrCtXvgRinDy
</commit_message>
<xml_diff>
--- a/tacografo/Manual_Tacografo_Digital.pptx
+++ b/tacografo/Manual_Tacografo_Digital.pptx
@@ -127,14 +127,14 @@
   <p:extLst>
     <p:ext uri="{521415D9-36F7-43E2-AB2F-B90AF26B5E84}">
       <p14:sectionLst xmlns:p14="http://schemas.microsoft.com/office/powerpoint/2010/main">
-        <p14:section name="Introdução" id="{aa02f55a-a583-8daf-c2f9-46333bc2c696}">
+        <p14:section name="Introdução" id="{8481e0ff-e53f-432a-a2d0-03081e3e599e}">
           <p14:sldIdLst>
             <p14:sldId id="256"/>
             <p14:sldId id="257"/>
             <p14:sldId id="258"/>
           </p14:sldIdLst>
         </p14:section>
-        <p14:section name="Parte 1 · Cadastrar" id="{aab8aebb-0016-6691-d7b2-4b51ccdafec0}">
+        <p14:section name="Parte 1 · Cadastrar" id="{358ddaa1-c869-5d15-dc4e-9c782a7633f1}">
           <p14:sldIdLst>
             <p14:sldId id="259"/>
             <p14:sldId id="260"/>
@@ -146,7 +146,7 @@
             <p14:sldId id="266"/>
           </p14:sldIdLst>
         </p14:section>
-        <p14:section name="Parte 2 · Conectar" id="{640ef9d8-5a52-d152-8e63-11349bbe5929}">
+        <p14:section name="Parte 2 · Conectar" id="{b3bf416d-492f-072a-e937-424c332247ef}">
           <p14:sldIdLst>
             <p14:sldId id="267"/>
             <p14:sldId id="268"/>
@@ -156,13 +156,13 @@
             <p14:sldId id="272"/>
           </p14:sldIdLst>
         </p14:section>
-        <p14:section name="Parte 3 · Desconectar" id="{d2e103b1-9cb8-9605-5a39-155880508fc0}">
+        <p14:section name="Parte 3 · Desconectar" id="{4722f970-3d2c-1fe3-0cb0-c4ff86f88581}">
           <p14:sldIdLst>
             <p14:sldId id="273"/>
             <p14:sldId id="274"/>
           </p14:sldIdLst>
         </p14:section>
-        <p14:section name="Encerramento" id="{21368106-6f7c-faa4-524c-68d2f3eb1aea}">
+        <p14:section name="Encerramento" id="{8ad3a5cc-170c-7cd7-402d-712f72314e6b}">
           <p14:sldIdLst>
             <p14:sldId id="275"/>
             <p14:sldId id="276"/>
@@ -2244,7 +2244,7 @@
           <a:p>
             <a:r>
               <a:rPr lang="en-US" dirty="0"/>
-              <a:t>Agora, digite o código do motorista. Ele é formado pelos cinco primeiros dígitos do C P F do motorista. Use as setas para escolher o número de cada dígito e pressione OK para passar para o próximo, até completar os cinco dígitos. No exemplo, o C P F começa com nove nove nove nove nove, então o código é nove nove nove nove nove.</a:t>
+              <a:t>Agora, digite o código do motorista. Ele é formado pelos primeiros dígitos do C P F do motorista: quatro ou cinco dígitos, dependendo do modelo do tacógrafo. Cada asterisco na tela representa um dígito a preencher. Use as setas para escolher o número de cada dígito e pressione OK para passar para o próximo. No exemplo, o modelo pede cinco dígitos e o C P F começa com nove nove nove nove nove, então o código é nove nove nove nove nove.</a:t>
             </a:r>
             <a:endParaRPr lang="en-US" dirty="0"/>
           </a:p>
@@ -12276,7 +12276,7 @@
                 <a:ea typeface="Montserrat Medium" pitchFamily="34" charset="-122"/>
                 <a:cs typeface="Montserrat Medium" pitchFamily="34" charset="-120"/>
               </a:rPr>
-              <a:t>O código são os 5 primeiros dígitos do CPF do motorista</a:t>
+              <a:t>Código: 4 ou 5 primeiros dígitos do CPF, conforme o modelo</a:t>
             </a:r>
             <a:endParaRPr lang="en-US" sz="1300" dirty="0"/>
           </a:p>
@@ -12297,7 +12297,7 @@
                 <a:ea typeface="Montserrat Medium" pitchFamily="34" charset="-122"/>
                 <a:cs typeface="Montserrat Medium" pitchFamily="34" charset="-120"/>
               </a:rPr>
-              <a:t>Use ▲ ou ▼ para escolher cada número e OK para avançar</a:t>
+              <a:t>Cada * é um dígito: ▲ ▼ escolhem, OK avança</a:t>
             </a:r>
             <a:endParaRPr lang="en-US" sz="1300" dirty="0"/>
           </a:p>
@@ -12318,7 +12318,7 @@
                 <a:ea typeface="Montserrat Medium" pitchFamily="34" charset="-122"/>
                 <a:cs typeface="Montserrat Medium" pitchFamily="34" charset="-120"/>
               </a:rPr>
-              <a:t>Exemplo: CPF que começa com 999.99 → código 99999</a:t>
+              <a:t>Exemplo: CPF 999.99… → código 99999</a:t>
             </a:r>
             <a:endParaRPr lang="en-US" sz="1300" dirty="0"/>
           </a:p>

</xml_diff>